<commit_message>
Gauntlet R1 build: L1 How to Talk to AI — thumbnail-first cover, real evaluation target for Exit #2, keys for every item, what-ifs, deck minutes = plan, listing per D2; title-slide chip wording
Co-Authored-By: Claude Fable 5.1 <noreply@anthropic.com>
Claude-Session: https://claude.ai/code/session_01VWaJFc84eoA3U4f2VjTKjw
</commit_message>
<xml_diff>
--- a/products/ai-prompting-101/dist/How to Talk to AI - Slides.pptx
+++ b/products/ai-prompting-101/dist/How to Talk to AI - Slides.pptx
@@ -512,7 +512,7 @@
           <a:p>
             <a:r>
               <a:rPr lang="en-US" dirty="0"/>
-              <a:t>Open on this slide while students settle. Worksheet: Cursed Wish Repair Shop, one per student.</a:t>
+              <a:t>Open on this slide while students settle. Worksheet: Cursed Wish Repair Shop, one per student (2 pages). Deck follows the lesson plan block for block; minute chips top-right match it.</a:t>
             </a:r>
             <a:endParaRPr lang="en-US" dirty="0"/>
           </a:p>
@@ -600,7 +600,7 @@
           <a:p>
             <a:r>
               <a:rPr lang="en-US" dirty="0"/>
-              <a:t>Bottom of the worksheet. Collect; the Teacher Guide has the scoring notes.</a:t>
+              <a:t>Solo, 4 minutes. Collect. KEY — Exit #1: any prompt with P, R and O present and specific; part two is proficient if it shows the short prompt lets the genie choose ("it would explain what 6th grade math is"). Exit #2: the planted fact is "first-ever photo of a black hole in 2009" — false; the Event Horizon Telescope image of M87's black hole was released in April 2019. Proficient = names that line AND a real place to check it (science textbook, NASA's website, a librarian). Accept a student who flags another line as checkable — spotting a checkable claim is the skill. Not accepted: "I'd check it on AI." WHAT IF "it all sounds right": "Which line has a number or a date in it? Start there."</a:t>
             </a:r>
             <a:endParaRPr lang="en-US" dirty="0"/>
           </a:p>
@@ -688,7 +688,7 @@
           <a:p>
             <a:r>
               <a:rPr lang="en-US" dirty="0"/>
-              <a:t>Close on this. Next in the unit: What's in the Playlist? — where an AI's answers even come from.</a:t>
+              <a:t>Close on this. This lesson stands alone. Next in the unit: What's in the Playlist (Lesson 2, sold separately) — where an AI's answers even come from.</a:t>
             </a:r>
             <a:endParaRPr lang="en-US" dirty="0"/>
           </a:p>
@@ -776,7 +776,7 @@
           <a:p>
             <a:r>
               <a:rPr lang="en-US" dirty="0"/>
-              <a:t>Take 3–4 wishes from the class and ruin every one, cheerfully. Stay in character. Then advance to the question.</a:t>
+              <a:t>Take 3–4 wishes from the class and ruin every one, cheerfully. Three improv moves cover any wish: (1) take a word literally — 'rich' becomes a name; (2) fill the missing detail badly — money becomes play money; (3) grant it in the least useful form — a story becomes 'Once there was a hero. The end.' Stay in character; the genie is never mean, just literal. WHAT IF a wish is inappropriate: 'The genie doesn't grant that one. Next wish.' Nobody volunteers? Wish first yourself: 'I wish for a snack' → 'Granted: one grain of rice.' Then advance to the question.</a:t>
             </a:r>
             <a:endParaRPr lang="en-US" dirty="0"/>
           </a:p>
@@ -864,7 +864,7 @@
           <a:p>
             <a:r>
               <a:rPr lang="en-US" dirty="0"/>
-              <a:t>Bridge: "Every AI job goes human, AI, human: you start it with the wish, the genie does the middle, and you check what comes back. Today you get good at both human parts."</a:t>
+              <a:t>Take two or three answers (the answer — the wish — stays off the slide until they say it). Then the bridge: "AI works like that genie. It doesn't know what you MEANT. It only knows what you SAID. Every AI job goes human, AI, human: you start it with the wish, the genie does the middle, and you check what comes back. Today you get good at both human parts." TRANSITION: "So how do you write a wish a genie can't twist? Lawyers figured this out a long time ago."</a:t>
             </a:r>
             <a:endParaRPr lang="en-US" dirty="0"/>
           </a:p>
@@ -952,7 +952,7 @@
           <a:p>
             <a:r>
               <a:rPr lang="en-US" dirty="0"/>
-              <a:t>Lawyers make contracts genie-proof with clauses. Strong prompts have three. Write P.R.O. on the board as you go.</a:t>
+              <a:t>Script: "Lawyers make contracts genie-proof with clauses. Strong prompts have three parts." Write P.R.O. on the board as you go. P: "Who is this for and what do you actually want?" R: "The rules — this is the part most people skip, and it's the part that stops the twist." O: "What does done look like? A list, a table, a paragraph?" Then advance: "Let's fix one together."</a:t>
             </a:r>
             <a:endParaRPr lang="en-US" dirty="0"/>
           </a:p>
@@ -1040,7 +1040,7 @@
           <a:p>
             <a:r>
               <a:rPr lang="en-US" dirty="0"/>
-              <a:t>Point at each clause: Purpose (essay, 7th grade history, printing press), Requirements (3 theses, 2 pieces of evidence each, don't write it), Output (bullet list). With devices: run the right-hand prompt live.</a:t>
+              <a:t>Build the right-hand prompt on the board one part at a time, naming each: Purpose (7th grade history essay, printing press), Requirements (3 theses, 2 pieces of evidence each, don't write it), Output (bullet list). With devices: run the right-hand prompt live. WHAT IF someone says it's too long: count it — three sentences. "Three sentences now, or forty pages of NASA history later. Your call."</a:t>
             </a:r>
             <a:endParaRPr lang="en-US" dirty="0"/>
           </a:p>
@@ -1128,7 +1128,7 @@
           <a:p>
             <a:r>
               <a:rPr lang="en-US" dirty="0"/>
-              <a:t>Say it plainly and move on; the Keep-it-100 box on the worksheet repeats it.</a:t>
+              <a:t>Say it plainly and move on; the 'Be real with yourself' box on the worksheet repeats it. TRANSITION: "Your turn. Page 1: three kids typed cursed wishes. Fix all three — every part, P, R and O, every time. Solo. Ten minutes."</a:t>
             </a:r>
             <a:endParaRPr lang="en-US" dirty="0"/>
           </a:p>
@@ -1216,7 +1216,7 @@
           <a:p>
             <a:r>
               <a:rPr lang="en-US" dirty="0"/>
-              <a:t>Circulate during Repair. In Break it, the twistable wishes are the teaching moment: twistable = needs more fine print.</a:t>
+              <a:t>REPAIR: circulate; read a stuck student's repair aloud in a genie voice. WHAT IF the same repair three times: "What does Mateo need that Yuki doesn't? A plan is not a story — O has to change." Finished early → Extension (a wish that can't be genie-proofed in 50 words). TRANSITION at 10 min: "Pens down. Swap sheets. You are now the Worst Genie Ever, and page 2 is where you do your damage." BREAK IT: put the next slide up. WHAT IF a partner ticks every box: make them say the twist out loud — no twist, the ✓ stands. SWAP BACK: "Sheets back with their owners. Genies, point at the ONE wish you could NOT twist. That's the one we want to hear." SHOWCASE: 2–3 pairs. WHAT IF the live AI answer is bad: "Which part of the wish let it do that?" Add a rule, run it again. Then: "Your OWN sheet, bottom of page 2. Before you write, one more rule about genies."</a:t>
             </a:r>
             <a:endParaRPr lang="en-US" dirty="0"/>
           </a:p>
@@ -1304,7 +1304,7 @@
           <a:p>
             <a:r>
               <a:rPr lang="en-US" dirty="0"/>
-              <a:t>Leave this up during Break it. Students score each of their partner's three wishes.</a:t>
+              <a:t>Leave this up during Break it. Students score their PARTNER's three wishes on the partner's sheet. Exemplar repairs to compare against — Amara: "I'm a 7th grader making a one-page science poster about black holes, due Friday. Give me 5 amazing facts, each under 20 words, written so a 5th grader could get it. No math formulas." Mateo: "I'm 12 and get $15 a week. I want $120 headphones in 10 weeks. Make a simple weekly savings plan as a table, and give 2 tips for not spending it on snacks." Yuki: "Write the opening paragraph (max 100 words) of an anime-style story about a shy kid whose sketchbook drawings come to life. Mysterious tone, end on a cliffhanger." Sneakiest-twist key: a twist counts if it obeys every word. Amara — no 'under 20 words' → each fact is a page. Mateo — no time limit → a 40-year plan, 6 cents a week. Yuki — no length → one sentence again.</a:t>
             </a:r>
             <a:endParaRPr lang="en-US" dirty="0"/>
           </a:p>
@@ -1392,7 +1392,7 @@
           <a:p>
             <a:r>
               <a:rPr lang="en-US" dirty="0"/>
-              <a:t>Teach this rule BEFORE the exit ticket. It is what Exit Ticket #2 assesses (ISTE 1.3.b).</a:t>
+              <a:t>First minute of the plan's 5-min Exit Ticket block; sheets are back with their owners. Script: "Genies are tricksters. AI can grant your wish with made-up facts, and sound sure. Anything checkable — a name, a date, a number — gets checked somewhere real before you use it." This rule is what Exit Ticket #2 assesses (ISTE 1.3.b). Do NOT reveal which line in the printed genie answer is wrong.</a:t>
             </a:r>
             <a:endParaRPr lang="en-US" dirty="0"/>
           </a:p>
@@ -2125,7 +2125,7 @@
         <p:spPr>
           <a:xfrm>
             <a:off x="3204972" y="3977640"/>
-            <a:ext cx="1485900" cy="310896"/>
+            <a:ext cx="2418588" cy="310896"/>
           </a:xfrm>
           <a:prstGeom prst="roundRect">
             <a:avLst>
@@ -2152,7 +2152,7 @@
         <p:spPr>
           <a:xfrm>
             <a:off x="3204972" y="3977640"/>
-            <a:ext cx="1485900" cy="310896"/>
+            <a:ext cx="2418588" cy="310896"/>
           </a:xfrm>
           <a:prstGeom prst="rect">
             <a:avLst/>
@@ -2176,7 +2176,7 @@
                 <a:ea typeface="Arial" pitchFamily="34" charset="-122"/>
                 <a:cs typeface="Arial" pitchFamily="34" charset="-120"/>
               </a:rPr>
-              <a:t>Works unplugged</a:t>
+              <a:t>No prep · No devices needed</a:t>
             </a:r>
             <a:endParaRPr lang="en-US" sz="1000" dirty="0"/>
           </a:p>
@@ -2352,7 +2352,7 @@
                 <a:ea typeface="Arial" pitchFamily="34" charset="-122"/>
                 <a:cs typeface="Arial" pitchFamily="34" charset="-120"/>
               </a:rPr>
-              <a:t>5 MIN</a:t>
+              <a:t>4 MIN</a:t>
             </a:r>
             <a:endParaRPr lang="en-US" sz="1000" dirty="0"/>
           </a:p>
@@ -2383,7 +2383,7 @@
               <a:buNone/>
             </a:pPr>
             <a:r>
-              <a:rPr lang="en-US" sz="2600" b="1" dirty="0">
+              <a:rPr lang="en-US" sz="1900" b="1" dirty="0">
                 <a:solidFill>
                   <a:srgbClr val="FFB020"/>
                 </a:solidFill>
@@ -2391,9 +2391,9 @@
                 <a:ea typeface="Arial" pitchFamily="34" charset="-122"/>
                 <a:cs typeface="Arial" pitchFamily="34" charset="-120"/>
               </a:rPr>
-              <a:t>Exit Ticket</a:t>
-            </a:r>
-            <a:endParaRPr lang="en-US" sz="2600" dirty="0"/>
+              <a:t>Exit Ticket — Last Check (your own sheet, page 2)</a:t>
+            </a:r>
+            <a:endParaRPr lang="en-US" sz="1900" dirty="0"/>
           </a:p>
         </p:txBody>
       </p:sp>
@@ -2434,7 +2434,7 @@
                 <a:ea typeface="Arial" pitchFamily="34" charset="-122"/>
                 <a:cs typeface="Arial" pitchFamily="34" charset="-120"/>
               </a:rPr>
-              <a:t>1.  Write one genie-proof prompt you could really use this week for another class.</a:t>
+              <a:t>1.  Write one genie-proof prompt you could really use this week for another class — P, R and O.</a:t>
             </a:r>
             <a:endParaRPr lang="en-US" sz="1800" dirty="0"/>
           </a:p>
@@ -2455,7 +2455,49 @@
                 <a:ea typeface="Arial" pitchFamily="34" charset="-122"/>
                 <a:cs typeface="Arial" pitchFamily="34" charset="-120"/>
               </a:rPr>
-              <a:t>2.  Name ONE thing in an AI answer you'd double-check — and where you'd check it. (No AI today? Imagine the answer you'd expect back.)</a:t>
+              <a:t>     Then one sentence: what would the genie have done with the short version (your first five words)?</a:t>
+            </a:r>
+            <a:endParaRPr lang="en-US" sz="1800" dirty="0"/>
+          </a:p>
+          <a:p>
+            <a:pPr marL="342900" indent="-342900">
+              <a:spcAft>
+                <a:spcPts val="800"/>
+              </a:spcAft>
+              <a:buSzPct val="100000"/>
+              <a:buChar char="■"/>
+            </a:pPr>
+            <a:r>
+              <a:rPr lang="en-US" sz="1800" dirty="0">
+                <a:solidFill>
+                  <a:srgbClr val="E8E8F5"/>
+                </a:solidFill>
+                <a:latin typeface="Arial" pitchFamily="34" charset="0"/>
+                <a:ea typeface="Arial" pitchFamily="34" charset="-122"/>
+                <a:cs typeface="Arial" pitchFamily="34" charset="-120"/>
+              </a:rPr>
+              <a:t>2.  Read the genie's answer to Amara's wish. Which line would you double-check?</a:t>
+            </a:r>
+            <a:endParaRPr lang="en-US" sz="1800" dirty="0"/>
+          </a:p>
+          <a:p>
+            <a:pPr marL="342900" indent="-342900">
+              <a:spcAft>
+                <a:spcPts val="800"/>
+              </a:spcAft>
+              <a:buSzPct val="100000"/>
+              <a:buChar char="■"/>
+            </a:pPr>
+            <a:r>
+              <a:rPr lang="en-US" sz="1800" dirty="0">
+                <a:solidFill>
+                  <a:srgbClr val="E8E8F5"/>
+                </a:solidFill>
+                <a:latin typeface="Arial" pitchFamily="34" charset="0"/>
+                <a:ea typeface="Arial" pitchFamily="34" charset="-122"/>
+                <a:cs typeface="Arial" pitchFamily="34" charset="-120"/>
+              </a:rPr>
+              <a:t>     Write that line — and where you would check it (a real place).</a:t>
             </a:r>
             <a:endParaRPr lang="en-US" sz="1800" dirty="0"/>
           </a:p>
@@ -2668,7 +2710,7 @@
                 <a:ea typeface="Arial" pitchFamily="34" charset="-122"/>
                 <a:cs typeface="Arial" pitchFamily="34" charset="-120"/>
               </a:rPr>
-              <a:t>Keep it 100: if the genie does your homework, your name is on a wish you never earned — and teachers can tell.</a:t>
+              <a:t>Be real with yourself: if the genie does your homework, your name is on a wish you never earned — and you'd know it.</a:t>
             </a:r>
             <a:endParaRPr lang="en-US" sz="1600" dirty="0"/>
           </a:p>
@@ -3323,7 +3365,7 @@
         <p:spPr>
           <a:xfrm>
             <a:off x="1737360" y="1188720"/>
-            <a:ext cx="6903720" cy="1873377"/>
+            <a:ext cx="6903720" cy="3406140"/>
           </a:xfrm>
           <a:prstGeom prst="rect">
             <a:avLst/>
@@ -3350,45 +3392,6 @@
               <a:t>The genie's — or the wish?</a:t>
             </a:r>
             <a:endParaRPr lang="en-US" sz="3000" dirty="0"/>
-          </a:p>
-        </p:txBody>
-      </p:sp>
-      <p:sp>
-        <p:nvSpPr>
-          <p:cNvPr id="8" name="Text 5"/>
-          <p:cNvSpPr txBox="1"/>
-          <p:nvPr/>
-        </p:nvSpPr>
-        <p:spPr>
-          <a:xfrm>
-            <a:off x="1737360" y="3199257"/>
-            <a:ext cx="6903720" cy="1395603"/>
-          </a:xfrm>
-          <a:prstGeom prst="rect">
-            <a:avLst/>
-          </a:prstGeom>
-          <a:noFill/>
-          <a:ln/>
-        </p:spPr>
-        <p:txBody>
-          <a:bodyPr wrap="square" lIns="0" tIns="0" rIns="0" bIns="0" rtlCol="0" anchor="t"/>
-          <a:lstStyle/>
-          <a:p>
-            <a:pPr indent="0" marL="0">
-              <a:buNone/>
-            </a:pPr>
-            <a:r>
-              <a:rPr lang="en-US" sz="1600" dirty="0">
-                <a:solidFill>
-                  <a:srgbClr val="A9A9C4"/>
-                </a:solidFill>
-                <a:latin typeface="Arial" pitchFamily="34" charset="0"/>
-                <a:ea typeface="Arial" pitchFamily="34" charset="-122"/>
-                <a:cs typeface="Arial" pitchFamily="34" charset="-120"/>
-              </a:rPr>
-              <a:t>AI works like that genie. It doesn't know what you MEANT. It only knows what you SAID.</a:t>
-            </a:r>
-            <a:endParaRPr lang="en-US" sz="1600" dirty="0"/>
           </a:p>
         </p:txBody>
       </p:sp>
@@ -3601,7 +3604,7 @@
                 <a:ea typeface="Arial" pitchFamily="34" charset="-122"/>
                 <a:cs typeface="Arial" pitchFamily="34" charset="-120"/>
               </a:rPr>
-              <a:t>Clauses of a Genie-Proof Wish</a:t>
+              <a:t>Parts of a Genie-Proof Wish</a:t>
             </a:r>
             <a:endParaRPr lang="en-US" sz="2600" dirty="0"/>
           </a:p>
@@ -3939,7 +3942,7 @@
                 <a:ea typeface="Arial" pitchFamily="34" charset="-122"/>
                 <a:cs typeface="Arial" pitchFamily="34" charset="-120"/>
               </a:rPr>
-              <a:t>The fine print: length, tone, format, include / avoid. This is what stops the genie from twisting your wish.</a:t>
+              <a:t>The rules: length, tone, format, include / leave out. This is what stops the genie from twisting your wish.</a:t>
             </a:r>
             <a:endParaRPr lang="en-US" sz="1400" dirty="0"/>
           </a:p>
@@ -4108,7 +4111,7 @@
                 <a:ea typeface="Arial" pitchFamily="34" charset="-122"/>
                 <a:cs typeface="Arial" pitchFamily="34" charset="-120"/>
               </a:rPr>
-              <a:t>What should the granted wish look like? A list? A paragraph? A table? A plan?</a:t>
+              <a:t>What should the finished answer look like? A list? A paragraph? A table? A plan?</a:t>
             </a:r>
             <a:endParaRPr lang="en-US" sz="1400" dirty="0"/>
           </a:p>
@@ -4257,7 +4260,7 @@
                 <a:ea typeface="Arial" pitchFamily="34" charset="-122"/>
                 <a:cs typeface="Arial" pitchFamily="34" charset="-120"/>
               </a:rPr>
-              <a:t>Model it live</a:t>
+              <a:t>Watch one get fixed</a:t>
             </a:r>
             <a:endParaRPr lang="en-US" sz="2600" dirty="0"/>
           </a:p>
@@ -4467,7 +4470,7 @@
                 <a:ea typeface="Arial" pitchFamily="34" charset="-122"/>
                 <a:cs typeface="Arial" pitchFamily="34" charset="-120"/>
               </a:rPr>
-              <a:t>"I'm writing a 5-paragraph essay for 7th grade history on why the printing press mattered. Give me 3 possible thesis statements and 2 pieces of evidence for each, as a bullet list. Don't write the essay for me."</a:t>
+              <a:t>"I'm writing a 7th grade history essay on the printing press. Give me 3 thesis statements and 2 pieces of evidence for each, as a bullet list. Don't write it for me."</a:t>
             </a:r>
             <a:endParaRPr lang="en-US" sz="1700" dirty="0"/>
           </a:p>
@@ -4694,7 +4697,7 @@
                 <a:ea typeface="Arial" pitchFamily="34" charset="-122"/>
                 <a:cs typeface="Arial" pitchFamily="34" charset="-120"/>
               </a:rPr>
-              <a:t>It gives a second opinion on YOUR work. It doesn't hand in work with your name on it. See the last clause — "don't write the essay for me."</a:t>
+              <a:t>It gives a second opinion on YOUR work. It doesn't hand in work with your name on it. See the last sentence — "don't write it for me."</a:t>
             </a:r>
             <a:endParaRPr lang="en-US" sz="1500" dirty="0"/>
           </a:p>
@@ -5012,7 +5015,7 @@
                 <a:ea typeface="Arial" pitchFamily="34" charset="-122"/>
                 <a:cs typeface="Arial" pitchFamily="34" charset="-120"/>
               </a:rPr>
-              <a:t>Repair   ·   9 min</a:t>
+              <a:t>Repair   ·   10 min</a:t>
             </a:r>
             <a:endParaRPr lang="en-US" sz="1500" dirty="0"/>
           </a:p>
@@ -5051,7 +5054,7 @@
                 <a:ea typeface="Arial" pitchFamily="34" charset="-122"/>
                 <a:cs typeface="Arial" pitchFamily="34" charset="-120"/>
               </a:rPr>
-              <a:t>Solo. Fix Amara's, Mateo's and Yuki's cursed wishes on your worksheet — all three P.R.O. clauses, every time.</a:t>
+              <a:t>Solo. Fix Amara's, Mateo's and Yuki's cursed wishes on page 1 — all three parts, P, R and O, every time.</a:t>
             </a:r>
             <a:endParaRPr lang="en-US" sz="1300" dirty="0"/>
           </a:p>
@@ -5154,7 +5157,7 @@
                 <a:ea typeface="Arial" pitchFamily="34" charset="-122"/>
                 <a:cs typeface="Arial" pitchFamily="34" charset="-120"/>
               </a:rPr>
-              <a:t>Break it   ·   8 min</a:t>
+              <a:t>Break it   ·   7 min</a:t>
             </a:r>
             <a:endParaRPr lang="en-US" sz="1500" dirty="0"/>
           </a:p>
@@ -5193,7 +5196,7 @@
                 <a:ea typeface="Arial" pitchFamily="34" charset="-122"/>
                 <a:cs typeface="Arial" pitchFamily="34" charset="-120"/>
               </a:rPr>
-              <a:t>Swap sheets. Be the Worst Genie Ever: twist each repaired wish as literally as you can, then score it with the checklist.</a:t>
+              <a:t>Swap sheets. Be the Worst Genie Ever on page 2 of your partner's sheet: say each twist out loud, tick the checklist, write your best one. Swap back.</a:t>
             </a:r>
             <a:endParaRPr lang="en-US" sz="1300" dirty="0"/>
           </a:p>
@@ -5527,7 +5530,7 @@
                 <a:ea typeface="Arial" pitchFamily="34" charset="-122"/>
                 <a:cs typeface="Arial" pitchFamily="34" charset="-120"/>
               </a:rPr>
-              <a:t>P — Clear purpose and audience?</a:t>
+              <a:t>P — Says what they want AND who it's for?</a:t>
             </a:r>
             <a:endParaRPr lang="en-US" sz="1800" dirty="0"/>
           </a:p>
@@ -5548,7 +5551,7 @@
                 <a:ea typeface="Arial" pitchFamily="34" charset="-122"/>
                 <a:cs typeface="Arial" pitchFamily="34" charset="-120"/>
               </a:rPr>
-              <a:t>R — At least 2 pieces of fine print (length, tone, format, include / avoid)?</a:t>
+              <a:t>R — Gives at least 2 rules (length, tone, format, include / leave out)?</a:t>
             </a:r>
             <a:endParaRPr lang="en-US" sz="1800" dirty="0"/>
           </a:p>
@@ -5569,7 +5572,7 @@
                 <a:ea typeface="Arial" pitchFamily="34" charset="-122"/>
                 <a:cs typeface="Arial" pitchFamily="34" charset="-120"/>
               </a:rPr>
-              <a:t>O — Says what the output should look like?</a:t>
+              <a:t>O — Says what the finished answer should look like?</a:t>
             </a:r>
             <a:endParaRPr lang="en-US" sz="1800" dirty="0"/>
           </a:p>
@@ -5590,7 +5593,7 @@
                 <a:ea typeface="Arial" pitchFamily="34" charset="-122"/>
                 <a:cs typeface="Arial" pitchFamily="34" charset="-120"/>
               </a:rPr>
-              <a:t>Genie test — ✓ only if the genie can't twist it</a:t>
+              <a:t>Genie test — you tried to twist it and couldn't? ✓ = genie-proof</a:t>
             </a:r>
             <a:endParaRPr lang="en-US" sz="1800" dirty="0"/>
           </a:p>

</xml_diff>

<commit_message>
Student-read fixes: L1 ghostwriter glossed on slide 6, 'put your hand over', 'Be honest with yourself', plain wording for the with-devices critique
Co-Authored-By: Claude Opus 5 <noreply@anthropic.com>
Claude-Session: https://claude.ai/code/session_01VWaJFc84eoA3U4f2VjTKjw
</commit_message>
<xml_diff>
--- a/products/ai-prompting-101/dist/How to Talk to AI - Slides.pptx
+++ b/products/ai-prompting-101/dist/How to Talk to AI - Slides.pptx
@@ -1128,7 +1128,7 @@
           <a:p>
             <a:r>
               <a:rPr lang="en-US" dirty="0"/>
-              <a:t>Say it plainly and move on; the 'Be real with yourself' box on the worksheet repeats it. TRANSITION: "Your turn. Page 1: three kids typed cursed wishes. Fix all three — every part, P, R and O, every time. Solo. Ten minutes."</a:t>
+              <a:t>Say it plainly and move on; the 'Be honest with yourself' box on the worksheet repeats it. TRANSITION: "Your turn. Page 1: three kids typed cursed wishes. Fix all three — every part, P, R and O, every time. Solo. Ten minutes."</a:t>
             </a:r>
             <a:endParaRPr lang="en-US" dirty="0"/>
           </a:p>
@@ -2710,7 +2710,7 @@
                 <a:ea typeface="Arial" pitchFamily="34" charset="-122"/>
                 <a:cs typeface="Arial" pitchFamily="34" charset="-120"/>
               </a:rPr>
-              <a:t>Be real with yourself: if the genie does your homework, your name is on a wish you never earned — and you'd know it.</a:t>
+              <a:t>Be honest with yourself: if the genie does your homework, your name is on a wish you never earned — and you'd know it.</a:t>
             </a:r>
             <a:endParaRPr lang="en-US" sz="1600" dirty="0"/>
           </a:p>
@@ -4697,7 +4697,7 @@
                 <a:ea typeface="Arial" pitchFamily="34" charset="-122"/>
                 <a:cs typeface="Arial" pitchFamily="34" charset="-120"/>
               </a:rPr>
-              <a:t>It gives a second opinion on YOUR work. It doesn't hand in work with your name on it. See the last sentence — "don't write it for me."</a:t>
+              <a:t>A ghostwriter writes the whole thing for you and lets you put your name on it. An editor gives a second opinion on YOUR work. See the last sentence — "don't write it for me."</a:t>
             </a:r>
             <a:endParaRPr lang="en-US" sz="1500" dirty="0"/>
           </a:p>
@@ -5338,7 +5338,7 @@
                 <a:ea typeface="Arial" pitchFamily="34" charset="-122"/>
                 <a:cs typeface="Arial" pitchFamily="34" charset="-120"/>
               </a:rPr>
-              <a:t>Two or three before-and-afters read aloud. With devices: run the best one live and critique what comes back.</a:t>
+              <a:t>Two or three before-and-afters read aloud. With devices: run the best one live and say what came out right and what came out wrong.</a:t>
             </a:r>
             <a:endParaRPr lang="en-US" sz="1300" dirty="0"/>
           </a:p>

</xml_diff>